<commit_message>
Fix pitch deck layout: wrapped URLs, overlaps, SDG note
Co-Authored-By: Claude Opus 5.5 <noreply@anthropic.com>
</commit_message>
<xml_diff>
--- a/slides/Shifa-Health-Companion.pptx
+++ b/slides/Shifa-Health-Companion.pptx
@@ -5186,8 +5186,8 @@
         </p:nvSpPr>
         <p:spPr>
           <a:xfrm>
-            <a:off x="685800" y="1234440"/>
-            <a:ext cx="2468880" cy="2651760"/>
+            <a:off x="685800" y="1188720"/>
+            <a:ext cx="2468880" cy="2468880"/>
           </a:xfrm>
           <a:prstGeom prst="roundRect">
             <a:avLst>
@@ -5397,8 +5397,8 @@
         </p:nvSpPr>
         <p:spPr>
           <a:xfrm>
-            <a:off x="3337560" y="1234440"/>
-            <a:ext cx="2468880" cy="2651760"/>
+            <a:off x="3337560" y="1188720"/>
+            <a:ext cx="2468880" cy="2468880"/>
           </a:xfrm>
           <a:prstGeom prst="roundRect">
             <a:avLst>
@@ -5608,8 +5608,8 @@
         </p:nvSpPr>
         <p:spPr>
           <a:xfrm>
-            <a:off x="5989320" y="1234440"/>
-            <a:ext cx="2468880" cy="2651760"/>
+            <a:off x="5989320" y="1188720"/>
+            <a:ext cx="2468880" cy="2468880"/>
           </a:xfrm>
           <a:prstGeom prst="roundRect">
             <a:avLst>
@@ -5819,7 +5819,7 @@
         </p:nvSpPr>
         <p:spPr>
           <a:xfrm>
-            <a:off x="685800" y="4023360"/>
+            <a:off x="685800" y="3767328"/>
             <a:ext cx="7772400" cy="274320"/>
           </a:xfrm>
           <a:prstGeom prst="rect">
@@ -7257,7 +7257,7 @@
               <a:buNone/>
             </a:pPr>
             <a:r>
-              <a:rPr lang="en-US" sz="1200" dirty="0">
+              <a:rPr lang="en-US" sz="950" dirty="0">
                 <a:solidFill>
                   <a:srgbClr val="00D4FF"/>
                 </a:solidFill>
@@ -7788,7 +7788,7 @@
                 <a:ea typeface="Arial Black" pitchFamily="34" charset="-122"/>
                 <a:cs typeface="Arial Black" pitchFamily="34" charset="-120"/>
               </a:rPr>
-              <a:t>One conversation → the right door</a:t>
+              <a:t>1 conversation → right door</a:t>
             </a:r>
             <a:endParaRPr lang="en-US" sz="2000" dirty="0"/>
           </a:p>
@@ -7924,9 +7924,9 @@
               <a:buNone/>
             </a:pPr>
             <a:r>
-              <a:rPr lang="en-US" sz="950" dirty="0">
-                <a:solidFill>
-                  <a:srgbClr val="5C7090"/>
+              <a:rPr lang="en-US" sz="1800" dirty="0" b="1">
+                <a:solidFill>
+                  <a:srgbClr val="FFFFFF"/>
                 </a:solidFill>
                 <a:latin typeface="Calibri" pitchFamily="34" charset="0"/>
                 <a:ea typeface="Calibri" pitchFamily="34" charset="-122"/>
@@ -7944,9 +7944,9 @@
               <a:buNone/>
             </a:pPr>
             <a:r>
-              <a:rPr lang="en-US" sz="950" dirty="0">
-                <a:solidFill>
-                  <a:srgbClr val="5C7090"/>
+              <a:rPr lang="en-US" sz="1800" dirty="0" b="1">
+                <a:solidFill>
+                  <a:srgbClr val="FFFFFF"/>
                 </a:solidFill>
                 <a:latin typeface="Calibri" pitchFamily="34" charset="0"/>
                 <a:ea typeface="Calibri" pitchFamily="34" charset="-122"/>
@@ -7964,9 +7964,9 @@
               <a:buNone/>
             </a:pPr>
             <a:r>
-              <a:rPr lang="en-US" sz="950" dirty="0">
-                <a:solidFill>
-                  <a:srgbClr val="5C7090"/>
+              <a:rPr lang="en-US" sz="1800" dirty="0" b="1">
+                <a:solidFill>
+                  <a:srgbClr val="FFFFFF"/>
                 </a:solidFill>
                 <a:latin typeface="Calibri" pitchFamily="34" charset="0"/>
                 <a:ea typeface="Calibri" pitchFamily="34" charset="-122"/>
@@ -9945,8 +9945,8 @@
         </p:nvSpPr>
         <p:spPr>
           <a:xfrm>
-            <a:off x="5669280" y="1051560"/>
-            <a:ext cx="3108960" cy="2606040"/>
+            <a:off x="5897880" y="1051560"/>
+            <a:ext cx="2880360" cy="2606040"/>
           </a:xfrm>
           <a:prstGeom prst="roundRect">
             <a:avLst>
@@ -10059,8 +10059,8 @@
         </p:blipFill>
         <p:spPr>
           <a:xfrm>
-            <a:off x="5760720" y="1188720"/>
-            <a:ext cx="2926080" cy="1828800"/>
+            <a:off x="5989320" y="1188720"/>
+            <a:ext cx="2697480" cy="1685925"/>
           </a:xfrm>
           <a:prstGeom prst="rect">
             <a:avLst/>
@@ -10075,8 +10075,8 @@
         </p:nvSpPr>
         <p:spPr>
           <a:xfrm>
-            <a:off x="5760720" y="3063240"/>
-            <a:ext cx="2926080" cy="502920"/>
+            <a:off x="5989320" y="2926080"/>
+            <a:ext cx="2697480" cy="502920"/>
           </a:xfrm>
           <a:prstGeom prst="rect">
             <a:avLst/>
@@ -12649,8 +12649,8 @@
         </p:nvSpPr>
         <p:spPr>
           <a:xfrm>
-            <a:off x="5669280" y="1051560"/>
-            <a:ext cx="3108960" cy="2606040"/>
+            <a:off x="5897880" y="1051560"/>
+            <a:ext cx="2880360" cy="2606040"/>
           </a:xfrm>
           <a:prstGeom prst="roundRect">
             <a:avLst>
@@ -12763,8 +12763,8 @@
         </p:blipFill>
         <p:spPr>
           <a:xfrm>
-            <a:off x="5852160" y="1188720"/>
-            <a:ext cx="2743200" cy="1714500"/>
+            <a:off x="5989320" y="1188720"/>
+            <a:ext cx="2697480" cy="1685925"/>
           </a:xfrm>
           <a:prstGeom prst="rect">
             <a:avLst/>
@@ -12779,8 +12779,8 @@
         </p:nvSpPr>
         <p:spPr>
           <a:xfrm>
-            <a:off x="5852160" y="2971800"/>
-            <a:ext cx="2743200" cy="365760"/>
+            <a:off x="5989320" y="2926080"/>
+            <a:ext cx="2697480" cy="365760"/>
           </a:xfrm>
           <a:prstGeom prst="rect">
             <a:avLst/>
@@ -13921,8 +13921,8 @@
         </p:nvSpPr>
         <p:spPr>
           <a:xfrm>
-            <a:off x="1828800" y="3246120"/>
-            <a:ext cx="5486400" cy="502920"/>
+            <a:off x="731520" y="3246120"/>
+            <a:ext cx="7680960" cy="502920"/>
           </a:xfrm>
           <a:prstGeom prst="roundRect">
             <a:avLst>
@@ -13948,8 +13948,8 @@
         </p:nvSpPr>
         <p:spPr>
           <a:xfrm>
-            <a:off x="1828800" y="3246120"/>
-            <a:ext cx="5486400" cy="502920"/>
+            <a:off x="731520" y="3246120"/>
+            <a:ext cx="7680960" cy="502920"/>
           </a:xfrm>
           <a:prstGeom prst="rect">
             <a:avLst/>
@@ -13965,7 +13965,7 @@
               <a:buNone/>
             </a:pPr>
             <a:r>
-              <a:rPr lang="en-US" sz="1500" dirty="0">
+              <a:rPr lang="en-US" sz="1100" dirty="0">
                 <a:solidFill>
                   <a:srgbClr val="FF9900"/>
                 </a:solidFill>

</xml_diff>